<commit_message>
fixed slope and such in 9
</commit_message>
<xml_diff>
--- a/docs/ecostats_lectures/lecture_09/09_01_lecture_powerpoint.pptx
+++ b/docs/ecostats_lectures/lecture_09/09_01_lecture_powerpoint.pptx
@@ -6141,7 +6141,7 @@
                 </a:pPr>
                 <a:r>
                   <a:rPr/>
-                  <a:t>The calculation for slope (b) is:</a:t>
+                  <a:t>The calculation for slope (m) is:</a:t>
                 </a:r>
                 <a:br/>
               </a:p>
@@ -6156,7 +6156,7 @@
                     </m:oMathParaPr>
                     <m:oMath>
                       <m:r>
-                        <m:t>b</m:t>
+                        <m:t>m</m:t>
                       </m:r>
                       <m:r>
                         <m:rPr>
@@ -6625,12 +6625,12 @@
                 </a:pPr>
                 <a:r>
                   <a:rPr/>
-                  <a:t>Intercept (a): </a:t>
+                  <a:t>Intercept (b): </a:t>
                 </a:r>
                 <a14:m>
                   <m:oMath xmlns:m="http://schemas.openxmlformats.org/officeDocument/2006/math">
                     <m:r>
-                      <m:t>a</m:t>
+                      <m:t>b</m:t>
                     </m:r>
                     <m:r>
                       <m:rPr>
@@ -6655,7 +6655,7 @@
                       <m:t>−</m:t>
                     </m:r>
                     <m:r>
-                      <m:t>b</m:t>
+                      <m:t>m</m:t>
                     </m:r>
                     <m:acc>
                       <m:accPr>

</xml_diff>